<commit_message>
Add accessible files for revisions
</commit_message>
<xml_diff>
--- a/fig/paper/Figure1.pptx
+++ b/fig/paper/Figure1.pptx
@@ -1294,7 +1294,7 @@
           <a:p>
             <a:fld id="{FC063745-338C-6544-A5D2-E98827DF5448}" type="datetimeFigureOut">
               <a:rPr lang="fr-FR" smtClean="0"/>
-              <a:t>08/12/2025</a:t>
+              <a:t>01/04/2026</a:t>
             </a:fld>
             <a:endParaRPr lang="fr-FR"/>
           </a:p>
@@ -1692,7 +1692,7 @@
           <a:p>
             <a:fld id="{313D89CB-2992-504C-8485-488CC4F9911A}" type="datetime1">
               <a:rPr lang="fr-FR" smtClean="0"/>
-              <a:t>08/12/2025</a:t>
+              <a:t>01/04/2026</a:t>
             </a:fld>
             <a:endParaRPr lang="fr-FR"/>
           </a:p>
@@ -1862,7 +1862,7 @@
           <a:p>
             <a:fld id="{2BD3FA36-0741-BA4C-B4B5-15DB72BF03A1}" type="datetime1">
               <a:rPr lang="fr-FR" smtClean="0"/>
-              <a:t>08/12/2025</a:t>
+              <a:t>01/04/2026</a:t>
             </a:fld>
             <a:endParaRPr lang="fr-FR"/>
           </a:p>
@@ -2042,7 +2042,7 @@
           <a:p>
             <a:fld id="{05CC4263-710C-0844-9D48-8CC43FD5ED7E}" type="datetime1">
               <a:rPr lang="fr-FR" smtClean="0"/>
-              <a:t>08/12/2025</a:t>
+              <a:t>01/04/2026</a:t>
             </a:fld>
             <a:endParaRPr lang="fr-FR"/>
           </a:p>
@@ -2212,7 +2212,7 @@
           <a:p>
             <a:fld id="{6D246230-44E5-7149-A9C0-9697288E77C8}" type="datetime1">
               <a:rPr lang="fr-FR" smtClean="0"/>
-              <a:t>08/12/2025</a:t>
+              <a:t>01/04/2026</a:t>
             </a:fld>
             <a:endParaRPr lang="fr-FR"/>
           </a:p>
@@ -2458,7 +2458,7 @@
           <a:p>
             <a:fld id="{B2E6C6B8-87C5-9042-8379-57F3FAAEA27C}" type="datetime1">
               <a:rPr lang="fr-FR" smtClean="0"/>
-              <a:t>08/12/2025</a:t>
+              <a:t>01/04/2026</a:t>
             </a:fld>
             <a:endParaRPr lang="fr-FR"/>
           </a:p>
@@ -2690,7 +2690,7 @@
           <a:p>
             <a:fld id="{743B3B7F-FB76-574A-A50A-1B727FB2048E}" type="datetime1">
               <a:rPr lang="fr-FR" smtClean="0"/>
-              <a:t>08/12/2025</a:t>
+              <a:t>01/04/2026</a:t>
             </a:fld>
             <a:endParaRPr lang="fr-FR"/>
           </a:p>
@@ -3057,7 +3057,7 @@
           <a:p>
             <a:fld id="{7EC74428-84BA-3B4B-B43B-C65A92789810}" type="datetime1">
               <a:rPr lang="fr-FR" smtClean="0"/>
-              <a:t>08/12/2025</a:t>
+              <a:t>01/04/2026</a:t>
             </a:fld>
             <a:endParaRPr lang="fr-FR"/>
           </a:p>
@@ -3175,7 +3175,7 @@
           <a:p>
             <a:fld id="{45F830CD-A919-E446-A668-AE81763E5C43}" type="datetime1">
               <a:rPr lang="fr-FR" smtClean="0"/>
-              <a:t>08/12/2025</a:t>
+              <a:t>01/04/2026</a:t>
             </a:fld>
             <a:endParaRPr lang="fr-FR"/>
           </a:p>
@@ -3270,7 +3270,7 @@
           <a:p>
             <a:fld id="{71FB997D-B6C7-6B4B-B04D-489C2B815439}" type="datetime1">
               <a:rPr lang="fr-FR" smtClean="0"/>
-              <a:t>08/12/2025</a:t>
+              <a:t>01/04/2026</a:t>
             </a:fld>
             <a:endParaRPr lang="fr-FR"/>
           </a:p>
@@ -3547,7 +3547,7 @@
           <a:p>
             <a:fld id="{58312FBC-18EE-0C4F-A90A-8E31346EA436}" type="datetime1">
               <a:rPr lang="fr-FR" smtClean="0"/>
-              <a:t>08/12/2025</a:t>
+              <a:t>01/04/2026</a:t>
             </a:fld>
             <a:endParaRPr lang="fr-FR"/>
           </a:p>
@@ -3804,7 +3804,7 @@
           <a:p>
             <a:fld id="{507D74E3-20C5-3843-8BB5-9F1E31E1AB26}" type="datetime1">
               <a:rPr lang="fr-FR" smtClean="0"/>
-              <a:t>08/12/2025</a:t>
+              <a:t>01/04/2026</a:t>
             </a:fld>
             <a:endParaRPr lang="fr-FR"/>
           </a:p>
@@ -4017,7 +4017,7 @@
           <a:p>
             <a:fld id="{BFC8098D-FEF3-9840-8384-7EB58056CD3E}" type="datetime1">
               <a:rPr lang="fr-FR" smtClean="0"/>
-              <a:t>08/12/2025</a:t>
+              <a:t>01/04/2026</a:t>
             </a:fld>
             <a:endParaRPr lang="fr-FR"/>
           </a:p>
@@ -11109,10 +11109,10 @@
           <p:nvPr/>
         </p:nvPicPr>
         <p:blipFill>
-          <a:blip r:embed="rId2">
+          <a:blip>
             <a:extLst>
               <a:ext uri="{96DAC541-7B7A-43D3-8B79-37D633B846F1}">
-                <asvg:svgBlip xmlns:asvg="http://schemas.microsoft.com/office/drawing/2016/SVG/main" r:embed="rId3"/>
+                <asvg:svgBlip xmlns:asvg="http://schemas.microsoft.com/office/drawing/2016/SVG/main" r:embed="rId2"/>
               </a:ext>
             </a:extLst>
           </a:blip>
@@ -11227,10 +11227,10 @@
           <p:nvPr/>
         </p:nvPicPr>
         <p:blipFill>
-          <a:blip r:embed="rId4">
+          <a:blip>
             <a:extLst>
               <a:ext uri="{96DAC541-7B7A-43D3-8B79-37D633B846F1}">
-                <asvg:svgBlip xmlns:asvg="http://schemas.microsoft.com/office/drawing/2016/SVG/main" r:embed="rId5"/>
+                <asvg:svgBlip xmlns:asvg="http://schemas.microsoft.com/office/drawing/2016/SVG/main" r:embed="rId3"/>
               </a:ext>
             </a:extLst>
           </a:blip>
@@ -13359,10 +13359,10 @@
                 <p:nvPr/>
               </p:nvPicPr>
               <p:blipFill>
-                <a:blip r:embed="rId6">
+                <a:blip>
                   <a:extLst>
                     <a:ext uri="{96DAC541-7B7A-43D3-8B79-37D633B846F1}">
-                      <asvg:svgBlip xmlns:asvg="http://schemas.microsoft.com/office/drawing/2016/SVG/main" r:embed="rId7"/>
+                      <asvg:svgBlip xmlns:asvg="http://schemas.microsoft.com/office/drawing/2016/SVG/main" r:embed="rId4"/>
                     </a:ext>
                   </a:extLst>
                 </a:blip>
@@ -13504,10 +13504,10 @@
                 <p:nvPr/>
               </p:nvPicPr>
               <p:blipFill>
-                <a:blip r:embed="rId8">
+                <a:blip>
                   <a:extLst>
                     <a:ext uri="{96DAC541-7B7A-43D3-8B79-37D633B846F1}">
-                      <asvg:svgBlip xmlns:asvg="http://schemas.microsoft.com/office/drawing/2016/SVG/main" r:embed="rId9"/>
+                      <asvg:svgBlip xmlns:asvg="http://schemas.microsoft.com/office/drawing/2016/SVG/main" r:embed="rId5"/>
                     </a:ext>
                   </a:extLst>
                 </a:blip>
@@ -13692,7 +13692,7 @@
             </p:xfrm>
             <a:graphic>
               <a:graphicData uri="http://schemas.openxmlformats.org/drawingml/2006/chart">
-                <c:chart xmlns:c="http://schemas.openxmlformats.org/drawingml/2006/chart" xmlns:r="http://schemas.openxmlformats.org/officeDocument/2006/relationships" r:id="rId10"/>
+                <c:chart xmlns:c="http://schemas.openxmlformats.org/drawingml/2006/chart" xmlns:r="http://schemas.openxmlformats.org/officeDocument/2006/relationships" r:id="rId6"/>
               </a:graphicData>
             </a:graphic>
           </p:graphicFrame>
@@ -13867,8 +13867,8 @@
             </a:p>
           </p:txBody>
         </p:sp>
-        <mc:AlternateContent xmlns:mc="http://schemas.openxmlformats.org/markup-compatibility/2006" xmlns:a14="http://schemas.microsoft.com/office/drawing/2010/main">
-          <mc:Choice Requires="a14">
+        <mc:AlternateContent xmlns:mc="http://schemas.openxmlformats.org/markup-compatibility/2006">
+          <mc:Choice xmlns:a14="http://schemas.microsoft.com/office/drawing/2010/main" Requires="a14">
             <p:sp>
               <p:nvSpPr>
                 <p:cNvPr id="31" name="ZoneTexte 30">
@@ -13904,17 +13904,17 @@
                         <m:jc m:val="centerGroup"/>
                       </m:oMathParaPr>
                       <m:oMath xmlns:m="http://schemas.openxmlformats.org/officeDocument/2006/math">
-                        <m:sSub>
-                          <m:sSubPr>
+                        <m:sSubSup>
+                          <m:sSubSupPr>
                             <m:ctrlPr>
-                              <a:rPr lang="fr-FR" sz="1013" i="1">
+                              <a:rPr lang="fr-FR" sz="1013" i="1" smtClean="0">
                                 <a:solidFill>
                                   <a:schemeClr val="accent2"/>
                                 </a:solidFill>
                                 <a:latin typeface="Cambria Math" panose="02040503050406030204" pitchFamily="18" charset="0"/>
                               </a:rPr>
                             </m:ctrlPr>
-                          </m:sSubPr>
+                          </m:sSubSupPr>
                           <m:e>
                             <m:r>
                               <a:rPr lang="fr-FR" sz="1013" i="1">
@@ -13928,7 +13928,7 @@
                           </m:e>
                           <m:sub>
                             <m:r>
-                              <a:rPr lang="fr-FR" sz="1013" i="1">
+                              <a:rPr lang="fr-FR" sz="1013" b="0" i="1" smtClean="0">
                                 <a:solidFill>
                                   <a:schemeClr val="accent2"/>
                                 </a:solidFill>
@@ -13936,17 +13936,10 @@
                               </a:rPr>
                               <m:t>𝑐</m:t>
                             </m:r>
+                          </m:sub>
+                          <m:sup>
                             <m:r>
-                              <a:rPr lang="fr-FR" sz="1013" i="1">
-                                <a:solidFill>
-                                  <a:schemeClr val="accent2"/>
-                                </a:solidFill>
-                                <a:latin typeface="Cambria Math" panose="02040503050406030204" pitchFamily="18" charset="0"/>
-                              </a:rPr>
-                              <m:t>,</m:t>
-                            </m:r>
-                            <m:r>
-                              <a:rPr lang="fr-FR" sz="1013" i="1">
+                              <a:rPr lang="fr-FR" sz="1013" b="0" i="1" smtClean="0">
                                 <a:solidFill>
                                   <a:schemeClr val="accent2"/>
                                 </a:solidFill>
@@ -13954,8 +13947,8 @@
                               </a:rPr>
                               <m:t>𝑗</m:t>
                             </m:r>
-                          </m:sub>
-                        </m:sSub>
+                          </m:sup>
+                        </m:sSubSup>
                         <m:d>
                           <m:dPr>
                             <m:ctrlPr>
@@ -14037,13 +14030,13 @@
                           </m:naryPr>
                           <m:sub>
                             <m:r>
-                              <a:rPr lang="fr-FR" sz="1013" i="1">
+                              <a:rPr lang="fr-FR" sz="1013" b="0" i="1" smtClean="0">
                                 <a:solidFill>
                                   <a:schemeClr val="accent2"/>
                                 </a:solidFill>
                                 <a:latin typeface="Cambria Math" panose="02040503050406030204" pitchFamily="18" charset="0"/>
                               </a:rPr>
-                              <m:t>𝑘</m:t>
+                              <m:t>𝑙</m:t>
                             </m:r>
                             <m:r>
                               <a:rPr lang="fr-FR" sz="1013" i="1">
@@ -14054,20 +14047,20 @@
                               </a:rPr>
                               <m:t>∈</m:t>
                             </m:r>
-                            <m:sSub>
-                              <m:sSubPr>
+                            <m:sSup>
+                              <m:sSupPr>
                                 <m:ctrlPr>
-                                  <a:rPr lang="fr-FR" sz="1013" i="1">
+                                  <a:rPr lang="fr-FR" sz="1013" b="0" i="1" smtClean="0">
                                     <a:solidFill>
                                       <a:schemeClr val="accent2"/>
                                     </a:solidFill>
                                     <a:latin typeface="Cambria Math" panose="02040503050406030204" pitchFamily="18" charset="0"/>
                                   </a:rPr>
                                 </m:ctrlPr>
-                              </m:sSubPr>
+                              </m:sSupPr>
                               <m:e>
                                 <m:r>
-                                  <a:rPr lang="fr-FR" sz="1013" i="1">
+                                  <a:rPr lang="fr-FR" sz="1013" b="0" i="1" smtClean="0">
                                     <a:solidFill>
                                       <a:schemeClr val="accent2"/>
                                     </a:solidFill>
@@ -14076,9 +14069,9 @@
                                   <m:t>𝐶</m:t>
                                 </m:r>
                               </m:e>
-                              <m:sub>
+                              <m:sup>
                                 <m:r>
-                                  <a:rPr lang="fr-FR" sz="1013" i="1">
+                                  <a:rPr lang="fr-FR" sz="1013" b="0" i="1" smtClean="0">
                                     <a:solidFill>
                                       <a:schemeClr val="accent2"/>
                                     </a:solidFill>
@@ -14086,8 +14079,8 @@
                                   </a:rPr>
                                   <m:t>𝑗</m:t>
                                 </m:r>
-                              </m:sub>
-                            </m:sSub>
+                              </m:sup>
+                            </m:sSup>
                             <m:r>
                               <a:rPr lang="fr-FR" sz="1013" i="1">
                                 <a:solidFill>
@@ -14150,40 +14143,15 @@
                                   </a:rPr>
                                   <m:t>{</m:t>
                                 </m:r>
-                                <m:sSub>
-                                  <m:sSubPr>
-                                    <m:ctrlPr>
-                                      <a:rPr lang="fr-FR" sz="1013" i="1">
-                                        <a:solidFill>
-                                          <a:schemeClr val="accent2"/>
-                                        </a:solidFill>
-                                        <a:latin typeface="Cambria Math" panose="02040503050406030204" pitchFamily="18" charset="0"/>
-                                      </a:rPr>
-                                    </m:ctrlPr>
-                                  </m:sSubPr>
-                                  <m:e>
-                                    <m:r>
-                                      <a:rPr lang="fr-FR" sz="1013" i="1">
-                                        <a:solidFill>
-                                          <a:schemeClr val="accent2"/>
-                                        </a:solidFill>
-                                        <a:latin typeface="Cambria Math" panose="02040503050406030204" pitchFamily="18" charset="0"/>
-                                      </a:rPr>
-                                      <m:t>𝐷</m:t>
-                                    </m:r>
-                                  </m:e>
-                                  <m:sub>
-                                    <m:r>
-                                      <a:rPr lang="fr-FR" sz="1013" i="1">
-                                        <a:solidFill>
-                                          <a:schemeClr val="accent2"/>
-                                        </a:solidFill>
-                                        <a:latin typeface="Cambria Math" panose="02040503050406030204" pitchFamily="18" charset="0"/>
-                                      </a:rPr>
-                                      <m:t>𝑘</m:t>
-                                    </m:r>
-                                  </m:sub>
-                                </m:sSub>
+                                <m:r>
+                                  <a:rPr lang="fr-FR" sz="1013" b="0" i="1" smtClean="0">
+                                    <a:solidFill>
+                                      <a:schemeClr val="accent2"/>
+                                    </a:solidFill>
+                                    <a:latin typeface="Cambria Math" panose="02040503050406030204" pitchFamily="18" charset="0"/>
+                                  </a:rPr>
+                                  <m:t>𝐷</m:t>
+                                </m:r>
                                 <m:d>
                                   <m:dPr>
                                     <m:ctrlPr>
@@ -14196,6 +14164,24 @@
                                     </m:ctrlPr>
                                   </m:dPr>
                                   <m:e>
+                                    <m:r>
+                                      <a:rPr lang="fr-FR" sz="1013" b="0" i="1" smtClean="0">
+                                        <a:solidFill>
+                                          <a:schemeClr val="accent2"/>
+                                        </a:solidFill>
+                                        <a:latin typeface="Cambria Math" panose="02040503050406030204" pitchFamily="18" charset="0"/>
+                                      </a:rPr>
+                                      <m:t>𝑙</m:t>
+                                    </m:r>
+                                    <m:r>
+                                      <a:rPr lang="fr-FR" sz="1013" b="0" i="1" smtClean="0">
+                                        <a:solidFill>
+                                          <a:schemeClr val="accent2"/>
+                                        </a:solidFill>
+                                        <a:latin typeface="Cambria Math" panose="02040503050406030204" pitchFamily="18" charset="0"/>
+                                      </a:rPr>
+                                      <m:t>,</m:t>
+                                    </m:r>
                                     <m:r>
                                       <a:rPr lang="fr-FR" sz="1013" i="1">
                                         <a:solidFill>
@@ -14246,7 +14232,7 @@
               </p:txBody>
             </p:sp>
           </mc:Choice>
-          <mc:Fallback xmlns="">
+          <mc:Fallback>
             <p:sp>
               <p:nvSpPr>
                 <p:cNvPr id="31" name="ZoneTexte 30">
@@ -14270,7 +14256,7 @@
                   <a:avLst/>
                 </a:prstGeom>
                 <a:blipFill>
-                  <a:blip r:embed="rId11"/>
+                  <a:blip r:embed="rId7"/>
                   <a:stretch>
                     <a:fillRect t="-95122" b="-131707"/>
                   </a:stretch>
@@ -14308,7 +14294,7 @@
               <p:spPr>
                 <a:xfrm>
                   <a:off x="3224511" y="4295281"/>
-                  <a:ext cx="2468153" cy="477375"/>
+                  <a:ext cx="2468153" cy="511358"/>
                 </a:xfrm>
                 <a:prstGeom prst="rect">
                   <a:avLst/>
@@ -14328,8 +14314,8 @@
                         <m:jc m:val="centerGroup"/>
                       </m:oMathParaPr>
                       <m:oMath xmlns:m="http://schemas.openxmlformats.org/officeDocument/2006/math">
-                        <m:sSub>
-                          <m:sSubPr>
+                        <m:sSubSup>
+                          <m:sSubSupPr>
                             <m:ctrlPr>
                               <a:rPr lang="fr-FR" sz="1013" i="1" smtClean="0">
                                 <a:solidFill>
@@ -14338,7 +14324,7 @@
                                 <a:latin typeface="Cambria Math" panose="02040503050406030204" pitchFamily="18" charset="0"/>
                               </a:rPr>
                             </m:ctrlPr>
-                          </m:sSubPr>
+                          </m:sSubSupPr>
                           <m:e>
                             <m:r>
                               <a:rPr lang="fr-FR" sz="1013" i="1">
@@ -14360,17 +14346,10 @@
                               </a:rPr>
                               <m:t>𝑒</m:t>
                             </m:r>
+                          </m:sub>
+                          <m:sup>
                             <m:r>
-                              <a:rPr lang="fr-FR" sz="1013" i="1">
-                                <a:solidFill>
-                                  <a:schemeClr val="accent5"/>
-                                </a:solidFill>
-                                <a:latin typeface="Cambria Math" panose="02040503050406030204" pitchFamily="18" charset="0"/>
-                              </a:rPr>
-                              <m:t>,</m:t>
-                            </m:r>
-                            <m:r>
-                              <a:rPr lang="fr-FR" sz="1013" i="1">
+                              <a:rPr lang="fr-FR" sz="1013" b="0" i="1" smtClean="0">
                                 <a:solidFill>
                                   <a:schemeClr val="accent5"/>
                                 </a:solidFill>
@@ -14378,8 +14357,8 @@
                               </a:rPr>
                               <m:t>𝑗</m:t>
                             </m:r>
-                          </m:sub>
-                        </m:sSub>
+                          </m:sup>
+                        </m:sSubSup>
                         <m:d>
                           <m:dPr>
                             <m:ctrlPr>
@@ -14461,16 +14440,13 @@
                           </m:naryPr>
                           <m:sub>
                             <m:r>
-                              <m:rPr>
-                                <m:brk m:alnAt="7"/>
-                              </m:rPr>
-                              <a:rPr lang="fr-FR" sz="1013" i="1">
+                              <a:rPr lang="fr-FR" sz="1013" b="0" i="1" smtClean="0">
                                 <a:solidFill>
                                   <a:schemeClr val="accent5"/>
                                 </a:solidFill>
                                 <a:latin typeface="Cambria Math" panose="02040503050406030204" pitchFamily="18" charset="0"/>
                               </a:rPr>
-                              <m:t>𝑚</m:t>
+                              <m:t>𝑘</m:t>
                             </m:r>
                             <m:r>
                               <a:rPr lang="fr-FR" sz="1013" i="1">
@@ -14481,15 +14457,40 @@
                               </a:rPr>
                               <m:t>∈</m:t>
                             </m:r>
-                            <m:r>
-                              <a:rPr lang="fr-FR" sz="1013" i="1">
-                                <a:solidFill>
-                                  <a:schemeClr val="accent5"/>
-                                </a:solidFill>
-                                <a:latin typeface="Cambria Math" panose="02040503050406030204" pitchFamily="18" charset="0"/>
-                              </a:rPr>
-                              <m:t>𝑅</m:t>
-                            </m:r>
+                            <m:sSup>
+                              <m:sSupPr>
+                                <m:ctrlPr>
+                                  <a:rPr lang="fr-FR" sz="1013" i="1">
+                                    <a:solidFill>
+                                      <a:schemeClr val="accent5"/>
+                                    </a:solidFill>
+                                    <a:latin typeface="Cambria Math" panose="02040503050406030204" pitchFamily="18" charset="0"/>
+                                  </a:rPr>
+                                </m:ctrlPr>
+                              </m:sSupPr>
+                              <m:e>
+                                <m:r>
+                                  <a:rPr lang="fr-FR" sz="1013" i="1">
+                                    <a:solidFill>
+                                      <a:schemeClr val="accent5"/>
+                                    </a:solidFill>
+                                    <a:latin typeface="Cambria Math" panose="02040503050406030204" pitchFamily="18" charset="0"/>
+                                  </a:rPr>
+                                  <m:t>𝑅</m:t>
+                                </m:r>
+                              </m:e>
+                              <m:sup>
+                                <m:r>
+                                  <a:rPr lang="fr-FR" sz="1013" b="0" i="1" smtClean="0">
+                                    <a:solidFill>
+                                      <a:schemeClr val="accent5"/>
+                                    </a:solidFill>
+                                    <a:latin typeface="Cambria Math" panose="02040503050406030204" pitchFamily="18" charset="0"/>
+                                  </a:rPr>
+                                  <m:t>𝑗</m:t>
+                                </m:r>
+                              </m:sup>
+                            </m:sSup>
                           </m:sub>
                           <m:sup/>
                           <m:e>
@@ -14530,20 +14531,20 @@
                                     </m:ctrlPr>
                                   </m:dPr>
                                   <m:e>
-                                    <m:sSub>
-                                      <m:sSubPr>
+                                    <m:sSup>
+                                      <m:sSupPr>
                                         <m:ctrlPr>
-                                          <a:rPr lang="fr-FR" sz="1013" i="1">
+                                          <a:rPr lang="fr-FR" sz="1013" b="0" i="1" smtClean="0">
                                             <a:solidFill>
                                               <a:schemeClr val="accent5"/>
                                             </a:solidFill>
                                             <a:latin typeface="Cambria Math" panose="02040503050406030204" pitchFamily="18" charset="0"/>
                                           </a:rPr>
                                         </m:ctrlPr>
-                                      </m:sSubPr>
+                                      </m:sSupPr>
                                       <m:e>
                                         <m:r>
-                                          <a:rPr lang="fr-FR" sz="1013" i="1">
+                                          <a:rPr lang="fr-FR" sz="1013" b="0" i="1" smtClean="0">
                                             <a:solidFill>
                                               <a:schemeClr val="accent5"/>
                                             </a:solidFill>
@@ -14552,9 +14553,9 @@
                                           <m:t>𝑟</m:t>
                                         </m:r>
                                       </m:e>
-                                      <m:sub>
+                                      <m:sup>
                                         <m:r>
-                                          <a:rPr lang="fr-FR" sz="1013" i="1">
+                                          <a:rPr lang="fr-FR" sz="1013" b="0" i="1" smtClean="0">
                                             <a:solidFill>
                                               <a:schemeClr val="accent5"/>
                                             </a:solidFill>
@@ -14562,8 +14563,8 @@
                                           </a:rPr>
                                           <m:t>𝑗</m:t>
                                         </m:r>
-                                      </m:sub>
-                                    </m:sSub>
+                                      </m:sup>
+                                    </m:sSup>
                                     <m:d>
                                       <m:dPr>
                                         <m:ctrlPr>
@@ -14606,13 +14607,13 @@
                                       <m:t>=</m:t>
                                     </m:r>
                                     <m:r>
-                                      <a:rPr lang="fr-FR" sz="1013" i="1">
+                                      <a:rPr lang="fr-FR" sz="1013" b="0" i="1" smtClean="0">
                                         <a:solidFill>
                                           <a:schemeClr val="accent5"/>
                                         </a:solidFill>
                                         <a:latin typeface="Cambria Math" panose="02040503050406030204" pitchFamily="18" charset="0"/>
                                       </a:rPr>
-                                      <m:t>𝑚</m:t>
+                                      <m:t>𝑘</m:t>
                                     </m:r>
                                   </m:e>
                                 </m:d>
@@ -14639,20 +14640,20 @@
                                 </m:ctrlPr>
                               </m:fPr>
                               <m:num>
-                                <m:sSub>
-                                  <m:sSubPr>
+                                <m:sSup>
+                                  <m:sSupPr>
                                     <m:ctrlPr>
-                                      <a:rPr lang="fr-FR" sz="1013" i="1">
+                                      <a:rPr lang="fr-FR" sz="1013" b="0" i="1" smtClean="0">
                                         <a:solidFill>
                                           <a:schemeClr val="accent5"/>
                                         </a:solidFill>
                                         <a:latin typeface="Cambria Math" panose="02040503050406030204" pitchFamily="18" charset="0"/>
                                       </a:rPr>
                                     </m:ctrlPr>
-                                  </m:sSubPr>
+                                  </m:sSupPr>
                                   <m:e>
                                     <m:r>
-                                      <a:rPr lang="fr-FR" sz="1013" i="1">
+                                      <a:rPr lang="fr-FR" sz="1013" b="0" i="1" smtClean="0">
                                         <a:solidFill>
                                           <a:schemeClr val="accent5"/>
                                         </a:solidFill>
@@ -14661,18 +14662,27 @@
                                       <m:t>𝐸</m:t>
                                     </m:r>
                                   </m:e>
-                                  <m:sub>
+                                  <m:sup>
                                     <m:r>
-                                      <a:rPr lang="fr-FR" sz="1013" i="1">
+                                      <a:rPr lang="fr-FR" sz="1013" b="0" i="1" smtClean="0">
                                         <a:solidFill>
                                           <a:schemeClr val="accent5"/>
                                         </a:solidFill>
                                         <a:latin typeface="Cambria Math" panose="02040503050406030204" pitchFamily="18" charset="0"/>
                                       </a:rPr>
-                                      <m:t>𝑚</m:t>
+                                      <m:t>𝑘</m:t>
                                     </m:r>
-                                  </m:sub>
-                                </m:sSub>
+                                  </m:sup>
+                                </m:sSup>
+                                <m:r>
+                                  <a:rPr lang="fr-FR" sz="1013" i="1" smtClean="0">
+                                    <a:solidFill>
+                                      <a:schemeClr val="accent5"/>
+                                    </a:solidFill>
+                                    <a:latin typeface="Cambria Math" panose="02040503050406030204" pitchFamily="18" charset="0"/>
+                                  </a:rPr>
+                                  <m:t> </m:t>
+                                </m:r>
                                 <m:r>
                                   <a:rPr lang="fr-FR" sz="1013" i="1">
                                     <a:solidFill>
@@ -14702,20 +14712,20 @@
                                 </m:r>
                               </m:num>
                               <m:den>
-                                <m:sSub>
-                                  <m:sSubPr>
+                                <m:sSup>
+                                  <m:sSupPr>
                                     <m:ctrlPr>
-                                      <a:rPr lang="fr-FR" sz="1013" i="1">
+                                      <a:rPr lang="fr-FR" sz="1013" b="0" i="1" smtClean="0">
                                         <a:solidFill>
                                           <a:schemeClr val="accent5"/>
                                         </a:solidFill>
                                         <a:latin typeface="Cambria Math" panose="02040503050406030204" pitchFamily="18" charset="0"/>
                                       </a:rPr>
                                     </m:ctrlPr>
-                                  </m:sSubPr>
+                                  </m:sSupPr>
                                   <m:e>
                                     <m:r>
-                                      <a:rPr lang="fr-FR" sz="1013" i="1">
+                                      <a:rPr lang="fr-FR" sz="1013" b="0" i="1" smtClean="0">
                                         <a:solidFill>
                                           <a:schemeClr val="accent5"/>
                                         </a:solidFill>
@@ -14724,18 +14734,18 @@
                                       <m:t>𝑉</m:t>
                                     </m:r>
                                   </m:e>
-                                  <m:sub>
+                                  <m:sup>
                                     <m:r>
-                                      <a:rPr lang="fr-FR" sz="1013" i="1">
+                                      <a:rPr lang="fr-FR" sz="1013" b="0" i="1" smtClean="0">
                                         <a:solidFill>
                                           <a:schemeClr val="accent5"/>
                                         </a:solidFill>
                                         <a:latin typeface="Cambria Math" panose="02040503050406030204" pitchFamily="18" charset="0"/>
                                       </a:rPr>
-                                      <m:t>𝑚</m:t>
+                                      <m:t>𝑘</m:t>
                                     </m:r>
-                                  </m:sub>
-                                </m:sSub>
+                                  </m:sup>
+                                </m:sSup>
                               </m:den>
                             </m:f>
                           </m:e>
@@ -14770,15 +14780,15 @@
               <p:spPr>
                 <a:xfrm>
                   <a:off x="3224511" y="4295281"/>
-                  <a:ext cx="2468153" cy="477375"/>
+                  <a:ext cx="2468153" cy="511358"/>
                 </a:xfrm>
                 <a:prstGeom prst="rect">
                   <a:avLst/>
                 </a:prstGeom>
                 <a:blipFill>
-                  <a:blip r:embed="rId12"/>
+                  <a:blip r:embed="rId8"/>
                   <a:stretch>
-                    <a:fillRect t="-102632" b="-150000"/>
+                    <a:fillRect t="-92683" b="-134146"/>
                   </a:stretch>
                 </a:blipFill>
               </p:spPr>
@@ -14934,10 +14944,10 @@
             <p:nvPr/>
           </p:nvPicPr>
           <p:blipFill>
-            <a:blip r:embed="rId6">
+            <a:blip>
               <a:extLst>
                 <a:ext uri="{96DAC541-7B7A-43D3-8B79-37D633B846F1}">
-                  <asvg:svgBlip xmlns:asvg="http://schemas.microsoft.com/office/drawing/2016/SVG/main" r:embed="rId7"/>
+                  <asvg:svgBlip xmlns:asvg="http://schemas.microsoft.com/office/drawing/2016/SVG/main" r:embed="rId4"/>
                 </a:ext>
               </a:extLst>
             </a:blip>
@@ -14970,10 +14980,10 @@
             <p:nvPr/>
           </p:nvPicPr>
           <p:blipFill>
-            <a:blip r:embed="rId8">
+            <a:blip>
               <a:extLst>
                 <a:ext uri="{96DAC541-7B7A-43D3-8B79-37D633B846F1}">
-                  <asvg:svgBlip xmlns:asvg="http://schemas.microsoft.com/office/drawing/2016/SVG/main" r:embed="rId9"/>
+                  <asvg:svgBlip xmlns:asvg="http://schemas.microsoft.com/office/drawing/2016/SVG/main" r:embed="rId5"/>
                 </a:ext>
               </a:extLst>
             </a:blip>
@@ -15149,10 +15159,10 @@
           <p:nvPr/>
         </p:nvPicPr>
         <p:blipFill>
-          <a:blip r:embed="rId13">
+          <a:blip>
             <a:extLst>
               <a:ext uri="{96DAC541-7B7A-43D3-8B79-37D633B846F1}">
-                <asvg:svgBlip xmlns:asvg="http://schemas.microsoft.com/office/drawing/2016/SVG/main" r:embed="rId14"/>
+                <asvg:svgBlip xmlns:asvg="http://schemas.microsoft.com/office/drawing/2016/SVG/main" r:embed="rId9"/>
               </a:ext>
             </a:extLst>
           </a:blip>
@@ -15185,10 +15195,10 @@
           <p:nvPr/>
         </p:nvPicPr>
         <p:blipFill>
-          <a:blip r:embed="rId15">
+          <a:blip>
             <a:extLst>
               <a:ext uri="{96DAC541-7B7A-43D3-8B79-37D633B846F1}">
-                <asvg:svgBlip xmlns:asvg="http://schemas.microsoft.com/office/drawing/2016/SVG/main" r:embed="rId16"/>
+                <asvg:svgBlip xmlns:asvg="http://schemas.microsoft.com/office/drawing/2016/SVG/main" r:embed="rId10"/>
               </a:ext>
             </a:extLst>
           </a:blip>
@@ -15938,10 +15948,10 @@
           <p:nvPr/>
         </p:nvPicPr>
         <p:blipFill>
-          <a:blip r:embed="rId20">
+          <a:blip>
             <a:extLst>
               <a:ext uri="{96DAC541-7B7A-43D3-8B79-37D633B846F1}">
-                <asvg:svgBlip xmlns:asvg="http://schemas.microsoft.com/office/drawing/2016/SVG/main" r:embed="rId21"/>
+                <asvg:svgBlip xmlns:asvg="http://schemas.microsoft.com/office/drawing/2016/SVG/main" r:embed="rId20"/>
               </a:ext>
             </a:extLst>
           </a:blip>
@@ -15974,10 +15984,10 @@
           <p:nvPr/>
         </p:nvPicPr>
         <p:blipFill>
-          <a:blip r:embed="rId15">
+          <a:blip>
             <a:extLst>
               <a:ext uri="{96DAC541-7B7A-43D3-8B79-37D633B846F1}">
-                <asvg:svgBlip xmlns:asvg="http://schemas.microsoft.com/office/drawing/2016/SVG/main" r:embed="rId22"/>
+                <asvg:svgBlip xmlns:asvg="http://schemas.microsoft.com/office/drawing/2016/SVG/main" r:embed="rId21"/>
               </a:ext>
             </a:extLst>
           </a:blip>
@@ -16010,10 +16020,10 @@
           <p:nvPr/>
         </p:nvPicPr>
         <p:blipFill>
-          <a:blip r:embed="rId23">
+          <a:blip>
             <a:extLst>
               <a:ext uri="{96DAC541-7B7A-43D3-8B79-37D633B846F1}">
-                <asvg:svgBlip xmlns:asvg="http://schemas.microsoft.com/office/drawing/2016/SVG/main" r:embed="rId24"/>
+                <asvg:svgBlip xmlns:asvg="http://schemas.microsoft.com/office/drawing/2016/SVG/main" r:embed="rId22"/>
               </a:ext>
             </a:extLst>
           </a:blip>
@@ -16296,10 +16306,10 @@
           <p:nvPr/>
         </p:nvPicPr>
         <p:blipFill>
-          <a:blip r:embed="rId26">
+          <a:blip>
             <a:extLst>
               <a:ext uri="{96DAC541-7B7A-43D3-8B79-37D633B846F1}">
-                <asvg:svgBlip xmlns:asvg="http://schemas.microsoft.com/office/drawing/2016/SVG/main" r:embed="rId27"/>
+                <asvg:svgBlip xmlns:asvg="http://schemas.microsoft.com/office/drawing/2016/SVG/main" r:embed="rId26"/>
               </a:ext>
             </a:extLst>
           </a:blip>
@@ -16332,10 +16342,10 @@
           <p:nvPr/>
         </p:nvPicPr>
         <p:blipFill>
-          <a:blip r:embed="rId28">
+          <a:blip>
             <a:extLst>
               <a:ext uri="{96DAC541-7B7A-43D3-8B79-37D633B846F1}">
-                <asvg:svgBlip xmlns:asvg="http://schemas.microsoft.com/office/drawing/2016/SVG/main" r:embed="rId29"/>
+                <asvg:svgBlip xmlns:asvg="http://schemas.microsoft.com/office/drawing/2016/SVG/main" r:embed="rId27"/>
               </a:ext>
             </a:extLst>
           </a:blip>
@@ -16368,10 +16378,10 @@
           <p:nvPr/>
         </p:nvPicPr>
         <p:blipFill>
-          <a:blip r:embed="rId30">
+          <a:blip>
             <a:extLst>
               <a:ext uri="{96DAC541-7B7A-43D3-8B79-37D633B846F1}">
-                <asvg:svgBlip xmlns:asvg="http://schemas.microsoft.com/office/drawing/2016/SVG/main" r:embed="rId31"/>
+                <asvg:svgBlip xmlns:asvg="http://schemas.microsoft.com/office/drawing/2016/SVG/main" r:embed="rId28"/>
               </a:ext>
             </a:extLst>
           </a:blip>

</xml_diff>

<commit_message>
Update gif generation script
</commit_message>
<xml_diff>
--- a/fig/paper/Figure1.pptx
+++ b/fig/paper/Figure1.pptx
@@ -1294,7 +1294,7 @@
           <a:p>
             <a:fld id="{FC063745-338C-6544-A5D2-E98827DF5448}" type="datetimeFigureOut">
               <a:rPr lang="fr-FR" smtClean="0"/>
-              <a:t>14/04/2026</a:t>
+              <a:t>04/06/2026</a:t>
             </a:fld>
             <a:endParaRPr lang="fr-FR"/>
           </a:p>
@@ -1692,7 +1692,7 @@
           <a:p>
             <a:fld id="{313D89CB-2992-504C-8485-488CC4F9911A}" type="datetime1">
               <a:rPr lang="fr-FR" smtClean="0"/>
-              <a:t>14/04/2026</a:t>
+              <a:t>04/06/2026</a:t>
             </a:fld>
             <a:endParaRPr lang="fr-FR"/>
           </a:p>
@@ -1862,7 +1862,7 @@
           <a:p>
             <a:fld id="{2BD3FA36-0741-BA4C-B4B5-15DB72BF03A1}" type="datetime1">
               <a:rPr lang="fr-FR" smtClean="0"/>
-              <a:t>14/04/2026</a:t>
+              <a:t>04/06/2026</a:t>
             </a:fld>
             <a:endParaRPr lang="fr-FR"/>
           </a:p>
@@ -2042,7 +2042,7 @@
           <a:p>
             <a:fld id="{05CC4263-710C-0844-9D48-8CC43FD5ED7E}" type="datetime1">
               <a:rPr lang="fr-FR" smtClean="0"/>
-              <a:t>14/04/2026</a:t>
+              <a:t>04/06/2026</a:t>
             </a:fld>
             <a:endParaRPr lang="fr-FR"/>
           </a:p>
@@ -2212,7 +2212,7 @@
           <a:p>
             <a:fld id="{6D246230-44E5-7149-A9C0-9697288E77C8}" type="datetime1">
               <a:rPr lang="fr-FR" smtClean="0"/>
-              <a:t>14/04/2026</a:t>
+              <a:t>04/06/2026</a:t>
             </a:fld>
             <a:endParaRPr lang="fr-FR"/>
           </a:p>
@@ -2458,7 +2458,7 @@
           <a:p>
             <a:fld id="{B2E6C6B8-87C5-9042-8379-57F3FAAEA27C}" type="datetime1">
               <a:rPr lang="fr-FR" smtClean="0"/>
-              <a:t>14/04/2026</a:t>
+              <a:t>04/06/2026</a:t>
             </a:fld>
             <a:endParaRPr lang="fr-FR"/>
           </a:p>
@@ -2690,7 +2690,7 @@
           <a:p>
             <a:fld id="{743B3B7F-FB76-574A-A50A-1B727FB2048E}" type="datetime1">
               <a:rPr lang="fr-FR" smtClean="0"/>
-              <a:t>14/04/2026</a:t>
+              <a:t>04/06/2026</a:t>
             </a:fld>
             <a:endParaRPr lang="fr-FR"/>
           </a:p>
@@ -3057,7 +3057,7 @@
           <a:p>
             <a:fld id="{7EC74428-84BA-3B4B-B43B-C65A92789810}" type="datetime1">
               <a:rPr lang="fr-FR" smtClean="0"/>
-              <a:t>14/04/2026</a:t>
+              <a:t>04/06/2026</a:t>
             </a:fld>
             <a:endParaRPr lang="fr-FR"/>
           </a:p>
@@ -3175,7 +3175,7 @@
           <a:p>
             <a:fld id="{45F830CD-A919-E446-A668-AE81763E5C43}" type="datetime1">
               <a:rPr lang="fr-FR" smtClean="0"/>
-              <a:t>14/04/2026</a:t>
+              <a:t>04/06/2026</a:t>
             </a:fld>
             <a:endParaRPr lang="fr-FR"/>
           </a:p>
@@ -3270,7 +3270,7 @@
           <a:p>
             <a:fld id="{71FB997D-B6C7-6B4B-B04D-489C2B815439}" type="datetime1">
               <a:rPr lang="fr-FR" smtClean="0"/>
-              <a:t>14/04/2026</a:t>
+              <a:t>04/06/2026</a:t>
             </a:fld>
             <a:endParaRPr lang="fr-FR"/>
           </a:p>
@@ -3547,7 +3547,7 @@
           <a:p>
             <a:fld id="{58312FBC-18EE-0C4F-A90A-8E31346EA436}" type="datetime1">
               <a:rPr lang="fr-FR" smtClean="0"/>
-              <a:t>14/04/2026</a:t>
+              <a:t>04/06/2026</a:t>
             </a:fld>
             <a:endParaRPr lang="fr-FR"/>
           </a:p>
@@ -3804,7 +3804,7 @@
           <a:p>
             <a:fld id="{507D74E3-20C5-3843-8BB5-9F1E31E1AB26}" type="datetime1">
               <a:rPr lang="fr-FR" smtClean="0"/>
-              <a:t>14/04/2026</a:t>
+              <a:t>04/06/2026</a:t>
             </a:fld>
             <a:endParaRPr lang="fr-FR"/>
           </a:p>
@@ -4017,7 +4017,7 @@
           <a:p>
             <a:fld id="{BFC8098D-FEF3-9840-8384-7EB58056CD3E}" type="datetime1">
               <a:rPr lang="fr-FR" smtClean="0"/>
-              <a:t>14/04/2026</a:t>
+              <a:t>04/06/2026</a:t>
             </a:fld>
             <a:endParaRPr lang="fr-FR"/>
           </a:p>
@@ -15254,8 +15254,8 @@
           </a:p>
         </p:txBody>
       </p:sp>
-      <mc:AlternateContent xmlns:mc="http://schemas.openxmlformats.org/markup-compatibility/2006">
-        <mc:Choice xmlns:a14="http://schemas.microsoft.com/office/drawing/2010/main" Requires="a14">
+      <mc:AlternateContent xmlns:mc="http://schemas.openxmlformats.org/markup-compatibility/2006" xmlns:a14="http://schemas.microsoft.com/office/drawing/2010/main">
+        <mc:Choice Requires="a14">
           <p:sp>
             <p:nvSpPr>
               <p:cNvPr id="87" name="ZoneTexte 86">
@@ -15317,7 +15317,7 @@
             </p:txBody>
           </p:sp>
         </mc:Choice>
-        <mc:Fallback>
+        <mc:Fallback xmlns="">
           <p:sp>
             <p:nvSpPr>
               <p:cNvPr id="87" name="ZoneTexte 86">
@@ -15362,8 +15362,8 @@
           </p:sp>
         </mc:Fallback>
       </mc:AlternateContent>
-      <mc:AlternateContent xmlns:mc="http://schemas.openxmlformats.org/markup-compatibility/2006">
-        <mc:Choice xmlns:a14="http://schemas.microsoft.com/office/drawing/2010/main" Requires="a14">
+      <mc:AlternateContent xmlns:mc="http://schemas.openxmlformats.org/markup-compatibility/2006" xmlns:a14="http://schemas.microsoft.com/office/drawing/2010/main">
+        <mc:Choice Requires="a14">
           <p:sp>
             <p:nvSpPr>
               <p:cNvPr id="37" name="ZoneTexte 36">
@@ -15413,7 +15413,7 @@
             </p:txBody>
           </p:sp>
         </mc:Choice>
-        <mc:Fallback>
+        <mc:Fallback xmlns="">
           <p:sp>
             <p:nvSpPr>
               <p:cNvPr id="37" name="ZoneTexte 36">
@@ -15458,8 +15458,8 @@
           </p:sp>
         </mc:Fallback>
       </mc:AlternateContent>
-      <mc:AlternateContent xmlns:mc="http://schemas.openxmlformats.org/markup-compatibility/2006" xmlns:a14="http://schemas.microsoft.com/office/drawing/2010/main">
-        <mc:Choice Requires="a14">
+      <mc:AlternateContent xmlns:mc="http://schemas.openxmlformats.org/markup-compatibility/2006">
+        <mc:Choice xmlns:a14="http://schemas.microsoft.com/office/drawing/2010/main" Requires="a14">
           <p:sp>
             <p:nvSpPr>
               <p:cNvPr id="76" name="ZoneTexte 75">
@@ -15474,7 +15474,7 @@
             </p:nvSpPr>
             <p:spPr>
               <a:xfrm>
-                <a:off x="3663009" y="2657971"/>
+                <a:off x="3621734" y="2657971"/>
                 <a:ext cx="401152" cy="261610"/>
               </a:xfrm>
               <a:prstGeom prst="rect">
@@ -15495,31 +15495,12 @@
                       <m:jc m:val="centerGroup"/>
                     </m:oMathParaPr>
                     <m:oMath xmlns:m="http://schemas.openxmlformats.org/officeDocument/2006/math">
-                      <m:sSub>
-                        <m:sSubPr>
-                          <m:ctrlPr>
-                            <a:rPr lang="fr-FR" sz="1100" i="1">
-                              <a:latin typeface="Cambria Math" panose="02040503050406030204" pitchFamily="18" charset="0"/>
-                            </a:rPr>
-                          </m:ctrlPr>
-                        </m:sSubPr>
-                        <m:e>
-                          <m:r>
-                            <a:rPr lang="fr-FR" sz="1100" i="1">
-                              <a:latin typeface="Cambria Math" panose="02040503050406030204" pitchFamily="18" charset="0"/>
-                            </a:rPr>
-                            <m:t>𝑉</m:t>
-                          </m:r>
-                        </m:e>
-                        <m:sub>
-                          <m:r>
-                            <a:rPr lang="fr-FR" sz="1100" i="1">
-                              <a:latin typeface="Cambria Math" panose="02040503050406030204" pitchFamily="18" charset="0"/>
-                            </a:rPr>
-                            <m:t>𝑚</m:t>
-                          </m:r>
-                        </m:sub>
-                      </m:sSub>
+                      <m:r>
+                        <a:rPr lang="fr-FR" sz="1100" b="0" i="1" smtClean="0">
+                          <a:latin typeface="Cambria Math" panose="02040503050406030204" pitchFamily="18" charset="0"/>
+                        </a:rPr>
+                        <m:t>𝑉</m:t>
+                      </m:r>
                     </m:oMath>
                   </m:oMathPara>
                 </a14:m>
@@ -15528,7 +15509,7 @@
             </p:txBody>
           </p:sp>
         </mc:Choice>
-        <mc:Fallback xmlns="">
+        <mc:Fallback>
           <p:sp>
             <p:nvSpPr>
               <p:cNvPr id="76" name="ZoneTexte 75">
@@ -15545,7 +15526,7 @@
             </p:nvSpPr>
             <p:spPr>
               <a:xfrm>
-                <a:off x="3663009" y="2657971"/>
+                <a:off x="3621734" y="2657971"/>
                 <a:ext cx="401152" cy="261610"/>
               </a:xfrm>
               <a:prstGeom prst="rect">

</xml_diff>